<commit_message>
PPT/进度汇报更新: RKNN/.rknn 路线改为 llama.cpp/Ollama 约束解码
- 答辩PPT: S5三套部署表/架构图/S11总结三步, 清除过时的 RKNN NPU/.rknn 表述,
  改为 llama.cpp/Ollama 约束解码(q4 .gguf) + 动态控制
- 进度汇报docx: 技术栈/交付物/指标(/sys 内存)/下一步全部同步 llama.cpp 约束解码路线,
  dynamic_control 7->10文件, 测试 8->12用例
- 指针指标内存标注'待上板实测确认'(不再写死 <1GB)
</commit_message>
<xml_diff>
--- a/1.1模块_答辩PPT.pptx
+++ b/1.1模块_答辩PPT.pptx
@@ -1782,6 +1782,10 @@
             <a:prstDash val="solid"/>
           </a:ln>
         </p:spPr>
+        <p:txBody>
+          <a:bodyPr/>
+          <a:p/>
+        </p:txBody>
       </p:sp>
       <p:sp>
         <p:nvSpPr>
@@ -1809,6 +1813,10 @@
             <a:prstDash val="solid"/>
           </a:ln>
         </p:spPr>
+        <p:txBody>
+          <a:bodyPr/>
+          <a:p/>
+        </p:txBody>
       </p:sp>
       <p:sp>
         <p:nvSpPr>
@@ -1836,6 +1844,10 @@
             <a:prstDash val="solid"/>
           </a:ln>
         </p:spPr>
+        <p:txBody>
+          <a:bodyPr/>
+          <a:p/>
+        </p:txBody>
       </p:sp>
       <p:sp>
         <p:nvSpPr>
@@ -1863,6 +1875,10 @@
             <a:prstDash val="solid"/>
           </a:ln>
         </p:spPr>
+        <p:txBody>
+          <a:bodyPr/>
+          <a:p/>
+        </p:txBody>
       </p:sp>
       <p:sp>
         <p:nvSpPr>
@@ -1890,6 +1906,10 @@
             <a:prstDash val="solid"/>
           </a:ln>
         </p:spPr>
+        <p:txBody>
+          <a:bodyPr/>
+          <a:p/>
+        </p:txBody>
       </p:sp>
       <p:sp>
         <p:nvSpPr>
@@ -1917,6 +1937,10 @@
             <a:prstDash val="solid"/>
           </a:ln>
         </p:spPr>
+        <p:txBody>
+          <a:bodyPr/>
+          <a:p/>
+        </p:txBody>
       </p:sp>
       <p:sp>
         <p:nvSpPr>
@@ -1944,6 +1968,10 @@
             <a:prstDash val="solid"/>
           </a:ln>
         </p:spPr>
+        <p:txBody>
+          <a:bodyPr/>
+          <a:p/>
+        </p:txBody>
       </p:sp>
       <p:sp>
         <p:nvSpPr>
@@ -2204,6 +2232,10 @@
             <a:prstDash val="solid"/>
           </a:ln>
         </p:spPr>
+        <p:txBody>
+          <a:bodyPr/>
+          <a:p/>
+        </p:txBody>
       </p:sp>
       <p:sp>
         <p:nvSpPr>
@@ -2273,6 +2305,10 @@
             <a:prstDash val="solid"/>
           </a:ln>
         </p:spPr>
+        <p:txBody>
+          <a:bodyPr/>
+          <a:p/>
+        </p:txBody>
       </p:sp>
       <p:sp>
         <p:nvSpPr>
@@ -3098,6 +3134,10 @@
             <a:prstDash val="solid"/>
           </a:ln>
         </p:spPr>
+        <p:txBody>
+          <a:bodyPr/>
+          <a:p/>
+        </p:txBody>
       </p:sp>
       <p:sp>
         <p:nvSpPr>
@@ -3587,6 +3627,10 @@
             <a:prstDash val="solid"/>
           </a:ln>
         </p:spPr>
+        <p:txBody>
+          <a:bodyPr/>
+          <a:p/>
+        </p:txBody>
       </p:sp>
       <p:sp>
         <p:nvSpPr>
@@ -3698,6 +3742,10 @@
             <a:prstDash val="solid"/>
           </a:ln>
         </p:spPr>
+        <p:txBody>
+          <a:bodyPr/>
+          <a:p/>
+        </p:txBody>
       </p:sp>
       <p:sp>
         <p:nvSpPr>
@@ -3809,6 +3857,10 @@
             <a:prstDash val="solid"/>
           </a:ln>
         </p:spPr>
+        <p:txBody>
+          <a:bodyPr/>
+          <a:p/>
+        </p:txBody>
       </p:sp>
       <p:sp>
         <p:nvSpPr>
@@ -3920,6 +3972,10 @@
             <a:prstDash val="solid"/>
           </a:ln>
         </p:spPr>
+        <p:txBody>
+          <a:bodyPr/>
+          <a:p/>
+        </p:txBody>
       </p:sp>
       <p:sp>
         <p:nvSpPr>
@@ -4031,6 +4087,10 @@
             <a:prstDash val="solid"/>
           </a:ln>
         </p:spPr>
+        <p:txBody>
+          <a:bodyPr/>
+          <a:p/>
+        </p:txBody>
       </p:sp>
       <p:sp>
         <p:nvSpPr>
@@ -4165,6 +4225,10 @@
             <a:prstDash val="solid"/>
           </a:ln>
         </p:spPr>
+        <p:txBody>
+          <a:bodyPr/>
+          <a:p/>
+        </p:txBody>
       </p:sp>
       <p:sp>
         <p:nvSpPr>
@@ -4234,6 +4298,10 @@
             <a:prstDash val="solid"/>
           </a:ln>
         </p:spPr>
+        <p:txBody>
+          <a:bodyPr/>
+          <a:p/>
+        </p:txBody>
       </p:sp>
       <p:sp>
         <p:nvSpPr>
@@ -4335,7 +4403,7 @@
                 <a:ea typeface="Microsoft YaHei" pitchFamily="34" charset="-122"/>
                 <a:cs typeface="Microsoft YaHei" pitchFamily="34" charset="-120"/>
               </a:rPr>
-              <a:t>3 套部署方案（WSL / Ollama / RKNN NPU）</a:t>
+              <a:t>3 套部署方案（WSL / Ollama / llama.cpp 约束解码）</a:t>
             </a:r>
             <a:endParaRPr lang="en-US" sz="1300" dirty="0"/>
           </a:p>
@@ -4398,7 +4466,7 @@
                 <a:ea typeface="Microsoft YaHei" pitchFamily="34" charset="-122"/>
                 <a:cs typeface="Microsoft YaHei" pitchFamily="34" charset="-120"/>
               </a:rPr>
-              <a:t>RK3588 适配（RKNN + CPU 兜底）</a:t>
+              <a:t>RK3588 适配（llama.cpp/Ollama 约束解码 + CPU 兜底）</a:t>
             </a:r>
             <a:endParaRPr lang="en-US" sz="1300" dirty="0"/>
           </a:p>
@@ -4430,6 +4498,10 @@
             <a:prstDash val="solid"/>
           </a:ln>
         </p:spPr>
+        <p:txBody>
+          <a:bodyPr/>
+          <a:p/>
+        </p:txBody>
       </p:sp>
       <p:sp>
         <p:nvSpPr>
@@ -4626,6 +4698,10 @@
             <a:prstDash val="solid"/>
           </a:ln>
         </p:spPr>
+        <p:txBody>
+          <a:bodyPr/>
+          <a:p/>
+        </p:txBody>
       </p:sp>
       <p:sp>
         <p:nvSpPr>
@@ -4706,7 +4782,7 @@
                 <a:ea typeface="Microsoft YaHei" pitchFamily="34" charset="-122"/>
                 <a:cs typeface="Microsoft YaHei" pitchFamily="34" charset="-120"/>
               </a:rPr>
-              <a:t>板子到手 → 转换模型（.rknn）</a:t>
+              <a:t>板子到手 → 部署 llama.cpp/Ollama + .gguf</a:t>
             </a:r>
             <a:endParaRPr lang="en-US" sz="1300" dirty="0"/>
           </a:p>
@@ -4887,6 +4963,10 @@
             <a:prstDash val="solid"/>
           </a:ln>
         </p:spPr>
+        <p:txBody>
+          <a:bodyPr/>
+          <a:p/>
+        </p:txBody>
       </p:sp>
       <p:sp>
         <p:nvSpPr>
@@ -4998,6 +5078,10 @@
             <a:prstDash val="solid"/>
           </a:ln>
         </p:spPr>
+        <p:txBody>
+          <a:bodyPr/>
+          <a:p/>
+        </p:txBody>
       </p:sp>
       <p:sp>
         <p:nvSpPr>
@@ -5151,6 +5235,10 @@
             <a:prstDash val="solid"/>
           </a:ln>
         </p:spPr>
+        <p:txBody>
+          <a:bodyPr/>
+          <a:p/>
+        </p:txBody>
       </p:sp>
       <p:sp>
         <p:nvSpPr>
@@ -5304,6 +5392,10 @@
             <a:prstDash val="solid"/>
           </a:ln>
         </p:spPr>
+        <p:txBody>
+          <a:bodyPr/>
+          <a:p/>
+        </p:txBody>
       </p:sp>
       <p:sp>
         <p:nvSpPr>
@@ -5457,6 +5549,10 @@
             <a:prstDash val="solid"/>
           </a:ln>
         </p:spPr>
+        <p:txBody>
+          <a:bodyPr/>
+          <a:p/>
+        </p:txBody>
       </p:sp>
       <p:sp>
         <p:nvSpPr>
@@ -5568,6 +5664,10 @@
             <a:prstDash val="solid"/>
           </a:ln>
         </p:spPr>
+        <p:txBody>
+          <a:bodyPr/>
+          <a:p/>
+        </p:txBody>
       </p:sp>
       <p:sp>
         <p:nvSpPr>
@@ -5805,6 +5905,10 @@
             <a:prstDash val="solid"/>
           </a:ln>
         </p:spPr>
+        <p:txBody>
+          <a:bodyPr/>
+          <a:p/>
+        </p:txBody>
       </p:sp>
       <p:sp>
         <p:nvSpPr>
@@ -5961,6 +6065,10 @@
             <a:prstDash val="solid"/>
           </a:ln>
         </p:spPr>
+        <p:txBody>
+          <a:bodyPr/>
+          <a:p/>
+        </p:txBody>
       </p:sp>
       <p:sp>
         <p:nvSpPr>
@@ -6030,6 +6138,10 @@
             <a:prstDash val="solid"/>
           </a:ln>
         </p:spPr>
+        <p:txBody>
+          <a:bodyPr/>
+          <a:p/>
+        </p:txBody>
       </p:sp>
       <p:sp>
         <p:nvSpPr>
@@ -6225,6 +6337,10 @@
             <a:prstDash val="solid"/>
           </a:ln>
         </p:spPr>
+        <p:txBody>
+          <a:bodyPr/>
+          <a:p/>
+        </p:txBody>
       </p:sp>
       <p:sp>
         <p:nvSpPr>
@@ -6500,6 +6616,10 @@
             <a:prstDash val="solid"/>
           </a:ln>
         </p:spPr>
+        <p:txBody>
+          <a:bodyPr/>
+          <a:p/>
+        </p:txBody>
       </p:sp>
       <p:sp>
         <p:nvSpPr>
@@ -6634,6 +6754,10 @@
             <a:prstDash val="solid"/>
           </a:ln>
         </p:spPr>
+        <p:txBody>
+          <a:bodyPr/>
+          <a:p/>
+        </p:txBody>
       </p:sp>
       <p:sp>
         <p:nvSpPr>
@@ -6713,7 +6837,7 @@
                 <a:ea typeface="Microsoft YaHei" pitchFamily="34" charset="-122"/>
                 <a:cs typeface="Microsoft YaHei" pitchFamily="34" charset="-120"/>
               </a:rPr>
-              <a:t>接口统一 · 三个版本（WSL / Ollama / RKNN）完全一致</a:t>
+              <a:t>接口统一 · 三个版本（WSL / Ollama / RK3588）完全一致</a:t>
             </a:r>
             <a:endParaRPr lang="en-US" sz="1400" dirty="0"/>
           </a:p>
@@ -6745,6 +6869,10 @@
             <a:prstDash val="solid"/>
           </a:ln>
         </p:spPr>
+        <p:txBody>
+          <a:bodyPr/>
+          <a:p/>
+        </p:txBody>
       </p:sp>
       <p:sp>
         <p:nvSpPr>
@@ -6770,6 +6898,10 @@
             <a:prstDash val="solid"/>
           </a:ln>
         </p:spPr>
+        <p:txBody>
+          <a:bodyPr/>
+          <a:p/>
+        </p:txBody>
       </p:sp>
       <p:sp>
         <p:nvSpPr>
@@ -7027,6 +7159,10 @@
             <a:prstDash val="solid"/>
           </a:ln>
         </p:spPr>
+        <p:txBody>
+          <a:bodyPr/>
+          <a:p/>
+        </p:txBody>
       </p:sp>
       <p:sp>
         <p:nvSpPr>
@@ -7052,6 +7188,10 @@
             <a:prstDash val="solid"/>
           </a:ln>
         </p:spPr>
+        <p:txBody>
+          <a:bodyPr/>
+          <a:p/>
+        </p:txBody>
       </p:sp>
       <p:sp>
         <p:nvSpPr>
@@ -7309,6 +7449,10 @@
             <a:prstDash val="solid"/>
           </a:ln>
         </p:spPr>
+        <p:txBody>
+          <a:bodyPr/>
+          <a:p/>
+        </p:txBody>
       </p:sp>
       <p:sp>
         <p:nvSpPr>
@@ -7334,6 +7478,10 @@
             <a:prstDash val="solid"/>
           </a:ln>
         </p:spPr>
+        <p:txBody>
+          <a:bodyPr/>
+          <a:p/>
+        </p:txBody>
       </p:sp>
       <p:sp>
         <p:nvSpPr>
@@ -7591,6 +7739,10 @@
             <a:prstDash val="solid"/>
           </a:ln>
         </p:spPr>
+        <p:txBody>
+          <a:bodyPr/>
+          <a:p/>
+        </p:txBody>
       </p:sp>
       <p:sp>
         <p:nvSpPr>
@@ -7616,6 +7768,10 @@
             <a:prstDash val="solid"/>
           </a:ln>
         </p:spPr>
+        <p:txBody>
+          <a:bodyPr/>
+          <a:p/>
+        </p:txBody>
       </p:sp>
       <p:sp>
         <p:nvSpPr>
@@ -7873,6 +8029,10 @@
             <a:prstDash val="solid"/>
           </a:ln>
         </p:spPr>
+        <p:txBody>
+          <a:bodyPr/>
+          <a:p/>
+        </p:txBody>
       </p:sp>
       <p:sp>
         <p:nvSpPr>
@@ -7898,6 +8058,10 @@
             <a:prstDash val="solid"/>
           </a:ln>
         </p:spPr>
+        <p:txBody>
+          <a:bodyPr/>
+          <a:p/>
+        </p:txBody>
       </p:sp>
       <p:sp>
         <p:nvSpPr>
@@ -8155,6 +8319,10 @@
             <a:prstDash val="solid"/>
           </a:ln>
         </p:spPr>
+        <p:txBody>
+          <a:bodyPr/>
+          <a:p/>
+        </p:txBody>
       </p:sp>
       <p:sp>
         <p:nvSpPr>
@@ -8331,6 +8499,10 @@
             <a:prstDash val="solid"/>
           </a:ln>
         </p:spPr>
+        <p:txBody>
+          <a:bodyPr/>
+          <a:p/>
+        </p:txBody>
       </p:sp>
       <p:sp>
         <p:nvSpPr>
@@ -8624,7 +8796,7 @@
                           <a:ea typeface="Microsoft YaHei" pitchFamily="34" charset="-122"/>
                           <a:cs typeface="Microsoft YaHei" pitchFamily="34" charset="-120"/>
                         </a:rPr>
-                        <a:t>RKNN NPU 版 (int8)</a:t>
+                        <a:t>llama.cpp 约束解码版 (q4)</a:t>
                       </a:r>
                       <a:endParaRPr lang="en-US" sz="1300" dirty="0">
                         <a:latin typeface="Microsoft YaHei" charset="0"/>
@@ -10582,6 +10754,10 @@
             <a:prstDash val="solid"/>
           </a:ln>
         </p:spPr>
+        <p:txBody>
+          <a:bodyPr/>
+          <a:p/>
+        </p:txBody>
       </p:sp>
       <p:sp>
         <p:nvSpPr>
@@ -10619,7 +10795,7 @@
                 <a:ea typeface="Microsoft YaHei" pitchFamily="34" charset="-122"/>
                 <a:cs typeface="Microsoft YaHei" pitchFamily="34" charset="-120"/>
               </a:rPr>
-              <a:t>主文件 sglang_1_1_module.py 已适配 RK3588（RKNN NPU + 动态控制 + CPU 兜底），同一套 5 个 API，调度员无需关心底层用哪个版本。</a:t>
+              <a:t>主文件 sglang_1_1_module.py 已适配 RK3588（llama.cpp/Ollama 约束解码 + 动态控制 + CPU 兜底），同一套 5 个 API，调度员无需关心底层用哪个版本。</a:t>
             </a:r>
             <a:endParaRPr lang="en-US" sz="1250" dirty="0"/>
           </a:p>
@@ -10674,6 +10850,10 @@
             <a:prstDash val="solid"/>
           </a:ln>
         </p:spPr>
+        <p:txBody>
+          <a:bodyPr/>
+          <a:p/>
+        </p:txBody>
       </p:sp>
       <p:sp>
         <p:nvSpPr>
@@ -10785,6 +10965,10 @@
             <a:prstDash val="solid"/>
           </a:ln>
         </p:spPr>
+        <p:txBody>
+          <a:bodyPr/>
+          <a:p/>
+        </p:txBody>
       </p:sp>
       <p:sp>
         <p:nvSpPr>
@@ -10896,6 +11080,10 @@
             <a:prstDash val="solid"/>
           </a:ln>
         </p:spPr>
+        <p:txBody>
+          <a:bodyPr/>
+          <a:p/>
+        </p:txBody>
       </p:sp>
       <p:sp>
         <p:nvSpPr>
@@ -11007,6 +11195,10 @@
             <a:prstDash val="solid"/>
           </a:ln>
         </p:spPr>
+        <p:txBody>
+          <a:bodyPr/>
+          <a:p/>
+        </p:txBody>
       </p:sp>
       <p:sp>
         <p:nvSpPr>
@@ -11118,6 +11310,10 @@
             <a:prstDash val="solid"/>
           </a:ln>
         </p:spPr>
+        <p:txBody>
+          <a:bodyPr/>
+          <a:p/>
+        </p:txBody>
       </p:sp>
       <p:sp>
         <p:nvSpPr>
@@ -11229,6 +11425,10 @@
             <a:prstDash val="solid"/>
           </a:ln>
         </p:spPr>
+        <p:txBody>
+          <a:bodyPr/>
+          <a:p/>
+        </p:txBody>
       </p:sp>
       <p:sp>
         <p:nvSpPr>
@@ -11363,6 +11563,10 @@
             <a:prstDash val="solid"/>
           </a:ln>
         </p:spPr>
+        <p:txBody>
+          <a:bodyPr/>
+          <a:p/>
+        </p:txBody>
       </p:sp>
       <p:sp>
         <p:nvSpPr>
@@ -11474,6 +11678,10 @@
             <a:prstDash val="solid"/>
           </a:ln>
         </p:spPr>
+        <p:txBody>
+          <a:bodyPr/>
+          <a:p/>
+        </p:txBody>
       </p:sp>
       <p:sp>
         <p:nvSpPr>
@@ -11585,6 +11793,10 @@
             <a:prstDash val="solid"/>
           </a:ln>
         </p:spPr>
+        <p:txBody>
+          <a:bodyPr/>
+          <a:p/>
+        </p:txBody>
       </p:sp>
       <p:sp>
         <p:nvSpPr>
@@ -11780,6 +11992,10 @@
             <a:prstDash val="solid"/>
           </a:ln>
         </p:spPr>
+        <p:txBody>
+          <a:bodyPr/>
+          <a:p/>
+        </p:txBody>
       </p:sp>
       <p:sp>
         <p:nvSpPr>
@@ -11975,6 +12191,10 @@
             <a:prstDash val="solid"/>
           </a:ln>
         </p:spPr>
+        <p:txBody>
+          <a:bodyPr/>
+          <a:p/>
+        </p:txBody>
       </p:sp>
       <p:sp>
         <p:nvSpPr>
@@ -12170,6 +12390,10 @@
             <a:prstDash val="solid"/>
           </a:ln>
         </p:spPr>
+        <p:txBody>
+          <a:bodyPr/>
+          <a:p/>
+        </p:txBody>
       </p:sp>
       <p:sp>
         <p:nvSpPr>
@@ -12291,7 +12515,7 @@
                 <a:ea typeface="Microsoft YaHei" pitchFamily="34" charset="-122"/>
                 <a:cs typeface="Microsoft YaHei" pitchFamily="34" charset="-120"/>
               </a:rPr>
-              <a:t>RKNN NPU / CPU 兜底</a:t>
+              <a:t>llama.cpp 约束解码 / CPU 兜底</a:t>
             </a:r>
             <a:endParaRPr lang="en-US" sz="1100" dirty="0"/>
           </a:p>
@@ -12323,6 +12547,10 @@
             <a:prstDash val="solid"/>
           </a:ln>
         </p:spPr>
+        <p:txBody>
+          <a:bodyPr/>
+          <a:p/>
+        </p:txBody>
       </p:sp>
       <p:sp>
         <p:nvSpPr>
@@ -12457,6 +12685,10 @@
             <a:prstDash val="solid"/>
           </a:ln>
         </p:spPr>
+        <p:txBody>
+          <a:bodyPr/>
+          <a:p/>
+        </p:txBody>
       </p:sp>
       <p:sp>
         <p:nvSpPr>
@@ -12568,6 +12800,10 @@
             <a:prstDash val="solid"/>
           </a:ln>
         </p:spPr>
+        <p:txBody>
+          <a:bodyPr/>
+          <a:p/>
+        </p:txBody>
       </p:sp>
       <p:sp>
         <p:nvSpPr>
@@ -12763,6 +12999,10 @@
             <a:prstDash val="solid"/>
           </a:ln>
         </p:spPr>
+        <p:txBody>
+          <a:bodyPr/>
+          <a:p/>
+        </p:txBody>
       </p:sp>
       <p:sp>
         <p:nvSpPr>
@@ -12958,6 +13198,10 @@
             <a:prstDash val="solid"/>
           </a:ln>
         </p:spPr>
+        <p:txBody>
+          <a:bodyPr/>
+          <a:p/>
+        </p:txBody>
       </p:sp>
       <p:sp>
         <p:nvSpPr>
@@ -13153,6 +13397,10 @@
             <a:prstDash val="solid"/>
           </a:ln>
         </p:spPr>
+        <p:txBody>
+          <a:bodyPr/>
+          <a:p/>
+        </p:txBody>
       </p:sp>
       <p:sp>
         <p:nvSpPr>
@@ -13348,6 +13596,10 @@
             <a:prstDash val="solid"/>
           </a:ln>
         </p:spPr>
+        <p:txBody>
+          <a:bodyPr/>
+          <a:p/>
+        </p:txBody>
       </p:sp>
       <p:sp>
         <p:nvSpPr>
@@ -13459,6 +13711,10 @@
             <a:prstDash val="solid"/>
           </a:ln>
         </p:spPr>
+        <p:txBody>
+          <a:bodyPr/>
+          <a:p/>
+        </p:txBody>
       </p:sp>
       <p:sp>
         <p:nvSpPr>
@@ -13570,6 +13826,10 @@
             <a:prstDash val="solid"/>
           </a:ln>
         </p:spPr>
+        <p:txBody>
+          <a:bodyPr/>
+          <a:p/>
+        </p:txBody>
       </p:sp>
       <p:sp>
         <p:nvSpPr>
@@ -13704,6 +13964,10 @@
             <a:prstDash val="solid"/>
           </a:ln>
         </p:spPr>
+        <p:txBody>
+          <a:bodyPr/>
+          <a:p/>
+        </p:txBody>
       </p:sp>
       <p:sp>
         <p:nvSpPr>
@@ -17964,6 +18228,10 @@
             <a:prstDash val="solid"/>
           </a:ln>
         </p:spPr>
+        <p:txBody>
+          <a:bodyPr/>
+          <a:p/>
+        </p:txBody>
       </p:sp>
       <p:sp>
         <p:nvSpPr>

</xml_diff>